<commit_message>
Go production-ready: remove all demo framing, run live on Arc only, prep mainnet migration
- Rename agent/src/demo.ts -> agent/src/dashboard.ts (live Arc orchestrator)
- Rename DEMO_TASK/DEMO_POLICY -> AGENT_TASK/AGENT_POLICY; delete local.ts + run-fleet.ts (local-chain paths)
- npm script demo -> start (root + agent); Dockerfile/compose/render/self-host run live against Arc
- Make chain config env-driven (ARC_CHAIN_ID/RPC/EXPLORER/NAME/IS_TESTNET) so mainnet migration is config, not a fork
- Scrub every 'demo' reference across source, docs, deck.html and deck.pptx; reword pitch 'live demo' -> 'live run'
- Refresh docs for Arc-only reality + mainnet migration notes; update test count to 75
- .env.example: document mainnet override vars
</commit_message>
<xml_diff>
--- a/docs/deck.pptx
+++ b/docs/deck.pptx
@@ -5530,7 +5530,7 @@
                 <a:ea typeface="Consolas" pitchFamily="34" charset="-122"/>
                 <a:cs typeface="Consolas" pitchFamily="34" charset="-120"/>
               </a:rPr>
-              <a:t>LIVE DEMO · ONE AUTONOMOUS RUN</a:t>
+              <a:t>LIVE RUN · ONE AUTONOMOUS RUN</a:t>
             </a:r>
             <a:endParaRPr lang="en-US" sz="1250" dirty="0"/>
           </a:p>
@@ -6800,7 +6800,7 @@
                 <a:ea typeface="Consolas" pitchFamily="34" charset="-122"/>
                 <a:cs typeface="Consolas" pitchFamily="34" charset="-120"/>
               </a:rPr>
-              <a:t>LIVE DEMO</a:t>
+              <a:t>LIVE RUN</a:t>
             </a:r>
             <a:endParaRPr lang="en-US" sz="1050" dirty="0"/>
           </a:p>

</xml_diff>